<commit_message>
Presentación 2 EduVerifica MX - demo Impact Lab
</commit_message>
<xml_diff>
--- a/EduVerifica_2slides.pptx
+++ b/EduVerifica_2slides.pptx
@@ -108,12 +108,12 @@
   <p:extLst>
     <p:ext uri="{521415D9-36F7-43E2-AB2F-B90AF26B5E84}">
       <p14:sectionLst xmlns:p14="http://schemas.microsoft.com/office/powerpoint/2010/main">
-        <p14:section name="Problema" id="{b9fe0981-d57d-9a53-4781-b6ab1160a701}">
+        <p14:section name="Problema" id="{cdbb816a-bcc9-2d9c-b8c5-80f3d1784032}">
           <p14:sldIdLst>
             <p14:sldId id="256"/>
           </p14:sldIdLst>
         </p14:section>
-        <p14:section name="Solución" id="{33c5d93e-e3f7-bf0a-1c13-90a022126280}">
+        <p14:section name="Solución" id="{64e16ea6-bc69-6781-dc09-784c7a3f40c3}">
           <p14:sldIdLst>
             <p14:sldId id="257"/>
           </p14:sldIdLst>

</xml_diff>